<commit_message>
about to implement permutation testing
</commit_message>
<xml_diff>
--- a/docs/notes_Sep14.pptx
+++ b/docs/notes_Sep14.pptx
@@ -228,7 +228,7 @@
           <a:p>
             <a:fld id="{0AB98493-CA63-4D0A-8042-ED8AF27DCFF3}" type="datetimeFigureOut">
               <a:rPr lang="en-US" smtClean="0"/>
-              <a:t>9/23/2023</a:t>
+              <a:t>10/12/2023</a:t>
             </a:fld>
             <a:endParaRPr lang="en-US"/>
           </a:p>
@@ -945,7 +945,7 @@
           <a:p>
             <a:fld id="{826B2E29-6454-4170-AF87-B006FFB35D00}" type="datetimeFigureOut">
               <a:rPr lang="en-US" smtClean="0"/>
-              <a:t>9/23/2023</a:t>
+              <a:t>10/12/2023</a:t>
             </a:fld>
             <a:endParaRPr lang="en-US" dirty="0"/>
           </a:p>
@@ -1143,7 +1143,7 @@
           <a:p>
             <a:fld id="{826B2E29-6454-4170-AF87-B006FFB35D00}" type="datetimeFigureOut">
               <a:rPr lang="en-US" smtClean="0"/>
-              <a:t>9/23/2023</a:t>
+              <a:t>10/12/2023</a:t>
             </a:fld>
             <a:endParaRPr lang="en-US"/>
           </a:p>
@@ -1351,7 +1351,7 @@
           <a:p>
             <a:fld id="{826B2E29-6454-4170-AF87-B006FFB35D00}" type="datetimeFigureOut">
               <a:rPr lang="en-US" smtClean="0"/>
-              <a:t>9/23/2023</a:t>
+              <a:t>10/12/2023</a:t>
             </a:fld>
             <a:endParaRPr lang="en-US"/>
           </a:p>
@@ -1595,7 +1595,7 @@
           <a:p>
             <a:fld id="{826B2E29-6454-4170-AF87-B006FFB35D00}" type="datetimeFigureOut">
               <a:rPr lang="en-US" smtClean="0"/>
-              <a:t>9/23/2023</a:t>
+              <a:t>10/12/2023</a:t>
             </a:fld>
             <a:endParaRPr lang="en-US"/>
           </a:p>
@@ -1870,7 +1870,7 @@
           <a:p>
             <a:fld id="{826B2E29-6454-4170-AF87-B006FFB35D00}" type="datetimeFigureOut">
               <a:rPr lang="en-US" smtClean="0"/>
-              <a:t>9/23/2023</a:t>
+              <a:t>10/12/2023</a:t>
             </a:fld>
             <a:endParaRPr lang="en-US"/>
           </a:p>
@@ -2135,7 +2135,7 @@
           <a:p>
             <a:fld id="{826B2E29-6454-4170-AF87-B006FFB35D00}" type="datetimeFigureOut">
               <a:rPr lang="en-US" smtClean="0"/>
-              <a:t>9/23/2023</a:t>
+              <a:t>10/12/2023</a:t>
             </a:fld>
             <a:endParaRPr lang="en-US"/>
           </a:p>
@@ -2547,7 +2547,7 @@
           <a:p>
             <a:fld id="{826B2E29-6454-4170-AF87-B006FFB35D00}" type="datetimeFigureOut">
               <a:rPr lang="en-US" smtClean="0"/>
-              <a:t>9/23/2023</a:t>
+              <a:t>10/12/2023</a:t>
             </a:fld>
             <a:endParaRPr lang="en-US"/>
           </a:p>
@@ -2688,7 +2688,7 @@
           <a:p>
             <a:fld id="{826B2E29-6454-4170-AF87-B006FFB35D00}" type="datetimeFigureOut">
               <a:rPr lang="en-US" smtClean="0"/>
-              <a:t>9/23/2023</a:t>
+              <a:t>10/12/2023</a:t>
             </a:fld>
             <a:endParaRPr lang="en-US"/>
           </a:p>
@@ -2801,7 +2801,7 @@
           <a:p>
             <a:fld id="{826B2E29-6454-4170-AF87-B006FFB35D00}" type="datetimeFigureOut">
               <a:rPr lang="en-US" smtClean="0"/>
-              <a:t>9/23/2023</a:t>
+              <a:t>10/12/2023</a:t>
             </a:fld>
             <a:endParaRPr lang="en-US"/>
           </a:p>
@@ -3112,7 +3112,7 @@
           <a:p>
             <a:fld id="{826B2E29-6454-4170-AF87-B006FFB35D00}" type="datetimeFigureOut">
               <a:rPr lang="en-US" smtClean="0"/>
-              <a:t>9/23/2023</a:t>
+              <a:t>10/12/2023</a:t>
             </a:fld>
             <a:endParaRPr lang="en-US"/>
           </a:p>
@@ -3403,7 +3403,7 @@
           <a:p>
             <a:fld id="{826B2E29-6454-4170-AF87-B006FFB35D00}" type="datetimeFigureOut">
               <a:rPr lang="en-US" smtClean="0"/>
-              <a:t>9/23/2023</a:t>
+              <a:t>10/12/2023</a:t>
             </a:fld>
             <a:endParaRPr lang="en-US"/>
           </a:p>
@@ -3646,7 +3646,7 @@
           <a:p>
             <a:fld id="{826B2E29-6454-4170-AF87-B006FFB35D00}" type="datetimeFigureOut">
               <a:rPr lang="en-US" smtClean="0"/>
-              <a:t>9/23/2023</a:t>
+              <a:t>10/12/2023</a:t>
             </a:fld>
             <a:endParaRPr lang="en-US"/>
           </a:p>

</xml_diff>